<commit_message>
Replace PPT sample template with latest download and bust asset cache
Co-authored-by: Cursor <cursoragent@cursor.com>
</commit_message>
<xml_diff>
--- a/templates/report-template.pptx
+++ b/templates/report-template.pptx
@@ -6912,42 +6912,6 @@
           </a:p>
         </p:txBody>
       </p:sp>
-      <p:pic>
-        <p:nvPicPr>
-          <p:cNvPr id="7" name="그림 6">
-            <a:extLst>
-              <a:ext uri="{FF2B5EF4-FFF2-40B4-BE49-F238E27FC236}">
-                <a16:creationId xmlns:a16="http://schemas.microsoft.com/office/drawing/2014/main" id="{D9E93822-C81E-1CDA-6A29-9EDB70A3308F}"/>
-              </a:ext>
-            </a:extLst>
-          </p:cNvPr>
-          <p:cNvPicPr>
-            <a:picLocks noChangeAspect="1"/>
-          </p:cNvPicPr>
-          <p:nvPr/>
-        </p:nvPicPr>
-        <p:blipFill>
-          <a:blip r:embed="rId3" cstate="print">
-            <a:extLst>
-              <a:ext uri="{28A0092B-C50C-407E-A947-70E740481C1C}">
-                <a14:useLocalDpi xmlns:a14="http://schemas.microsoft.com/office/drawing/2010/main" val="0"/>
-              </a:ext>
-            </a:extLst>
-          </a:blip>
-          <a:stretch>
-            <a:fillRect/>
-          </a:stretch>
-        </p:blipFill>
-        <p:spPr>
-          <a:xfrm>
-            <a:off x="0" y="1039718"/>
-            <a:ext cx="6858000" cy="8158257"/>
-          </a:xfrm>
-          <a:prstGeom prst="rect">
-            <a:avLst/>
-          </a:prstGeom>
-        </p:spPr>
-      </p:pic>
     </p:spTree>
     <p:extLst>
       <p:ext uri="{BB962C8B-B14F-4D97-AF65-F5344CB8AC3E}">

</xml_diff>

<commit_message>
Use new template and replace thisname with project name
Co-authored-by: Cursor <cursoragent@cursor.com>
</commit_message>
<xml_diff>
--- a/templates/report-template.pptx
+++ b/templates/report-template.pptx
@@ -4862,8 +4862,8 @@
         </p:nvSpPr>
         <p:spPr bwMode="auto">
           <a:xfrm>
-            <a:off x="1560748" y="249555"/>
-            <a:ext cx="3890810" cy="261610"/>
+            <a:off x="1885356" y="249555"/>
+            <a:ext cx="3241593" cy="261610"/>
           </a:xfrm>
           <a:prstGeom prst="rect">
             <a:avLst/>
@@ -5034,27 +5034,17 @@
                 <a:latin typeface="휴먼옛체" charset="0"/>
                 <a:ea typeface="휴먼옛체" charset="0"/>
               </a:rPr>
-              <a:t>Kwater</a:t>
+              <a:t>thisname</a:t>
             </a:r>
             <a:r>
-              <a:rPr lang="en-US" altLang="ko-KR" sz="1100" b="0" dirty="0">
+              <a:rPr lang="ko-KR" altLang="en-US" sz="1100" b="0" dirty="0">
                 <a:solidFill>
                   <a:schemeClr val="bg1"/>
                 </a:solidFill>
                 <a:latin typeface="휴먼옛체" charset="0"/>
                 <a:ea typeface="휴먼옛체" charset="0"/>
               </a:rPr>
-              <a:t> </a:t>
-            </a:r>
-            <a:r>
-              <a:rPr lang="ko-KR" altLang="en-US" sz="1100" b="0" dirty="0">
-                <a:solidFill>
-                  <a:schemeClr val="bg1"/>
-                </a:solidFill>
-                <a:latin typeface="휴먼옛체" charset="0"/>
-                <a:ea typeface="휴먼옛체" charset="0"/>
-              </a:rPr>
-              <a:t>전주권지사 밀폐공간 </a:t>
+              <a:t> 밀폐공간 </a:t>
             </a:r>
             <a:r>
               <a:rPr lang="ko-KR" altLang="en-US" sz="1100" b="0" dirty="0" err="1">
@@ -6332,22 +6322,12 @@
                 <a:latin typeface="양재튼튼체B" charset="0"/>
                 <a:ea typeface="문체부 바탕체" charset="0"/>
               </a:rPr>
-              <a:t>Kwater</a:t>
+              <a:t>thisname</a:t>
             </a:r>
-            <a:r>
-              <a:rPr lang="ko-KR" altLang="ko-KR" sz="2600" b="1" dirty="0">
-                <a:latin typeface="양재튼튼체B" charset="0"/>
-                <a:ea typeface="문체부 바탕체" charset="0"/>
-              </a:rPr>
-              <a:t> </a:t>
-            </a:r>
-            <a:r>
-              <a:rPr lang="ko-KR" altLang="en-US" sz="2600" b="1" dirty="0">
-                <a:latin typeface="양재튼튼체B" charset="0"/>
-                <a:ea typeface="문체부 바탕체" charset="0"/>
-              </a:rPr>
-              <a:t>전주권지사</a:t>
-            </a:r>
+            <a:endParaRPr lang="ko-KR" altLang="en-US" sz="2600" b="1" dirty="0">
+              <a:latin typeface="양재튼튼체B" charset="0"/>
+              <a:ea typeface="문체부 바탕체" charset="0"/>
+            </a:endParaRPr>
           </a:p>
           <a:p>
             <a:pPr marL="0" indent="0" algn="ctr" eaLnBrk="1" hangingPunct="1">
@@ -6897,7 +6877,7 @@
                 <a:latin typeface="휴먼엑스포"/>
                 <a:ea typeface="문체부 바탕체"/>
               </a:rPr>
-              <a:t>전주권지사 개략도</a:t>
+              <a:t>개략도</a:t>
             </a:r>
             <a:r>
               <a:rPr lang="en-US" altLang="ko-KR" sz="1400" b="1" dirty="0">
@@ -8636,14 +8616,14 @@
               <a:t>&lt; </a:t>
             </a:r>
             <a:r>
-              <a:rPr lang="ko-KR" altLang="en-US" sz="1400" b="1" dirty="0">
+              <a:rPr lang="en-US" altLang="ko-KR" sz="1400" b="1" dirty="0" err="1">
                 <a:solidFill>
                   <a:schemeClr val="tx1"/>
                 </a:solidFill>
                 <a:latin typeface="휴먼엑스포"/>
                 <a:ea typeface="문체부 바탕체"/>
               </a:rPr>
-              <a:t>전주권지사</a:t>
+              <a:t>thisname</a:t>
             </a:r>
             <a:r>
               <a:rPr lang="en-US" altLang="ko-KR" sz="1400" b="1" dirty="0">
@@ -8693,7 +8673,7 @@
         <p:spPr>
           <a:xfrm>
             <a:off x="-1" y="4591249"/>
-            <a:ext cx="6459220" cy="900246"/>
+            <a:ext cx="6459220" cy="253916"/>
           </a:xfrm>
           <a:prstGeom prst="rect">
             <a:avLst/>
@@ -8711,252 +8691,13 @@
               <a:buChar char="•"/>
             </a:pPr>
             <a:r>
-              <a:rPr lang="en-US" altLang="ko-KR" sz="1050" b="1" dirty="0">
+              <a:rPr lang="ko-KR" altLang="en-US" sz="1050" b="1" dirty="0">
                 <a:solidFill>
                   <a:srgbClr val="FF0000"/>
                 </a:solidFill>
               </a:rPr>
-              <a:t>3</a:t>
+              <a:t>특이사항</a:t>
             </a:r>
-            <a:r>
-              <a:rPr lang="ko-KR" altLang="en-US" sz="1050" b="1" dirty="0">
-                <a:solidFill>
-                  <a:srgbClr val="FF0000"/>
-                </a:solidFill>
-              </a:rPr>
-              <a:t>단계</a:t>
-            </a:r>
-            <a:r>
-              <a:rPr lang="en-US" altLang="ko-KR" sz="1050" b="1" dirty="0">
-                <a:solidFill>
-                  <a:srgbClr val="FF0000"/>
-                </a:solidFill>
-              </a:rPr>
-              <a:t>, </a:t>
-            </a:r>
-            <a:r>
-              <a:rPr lang="ko-KR" altLang="en-US" sz="1050" b="1" dirty="0">
-                <a:solidFill>
-                  <a:srgbClr val="FF0000"/>
-                </a:solidFill>
-              </a:rPr>
-              <a:t>생활</a:t>
-            </a:r>
-            <a:r>
-              <a:rPr lang="en-US" altLang="ko-KR" sz="1050" b="1" dirty="0">
-                <a:solidFill>
-                  <a:srgbClr val="FF0000"/>
-                </a:solidFill>
-              </a:rPr>
-              <a:t>, </a:t>
-            </a:r>
-            <a:r>
-              <a:rPr lang="ko-KR" altLang="en-US" sz="1050" b="1" dirty="0">
-                <a:solidFill>
-                  <a:srgbClr val="FF0000"/>
-                </a:solidFill>
-              </a:rPr>
-              <a:t>공업 유출 </a:t>
-            </a:r>
-            <a:r>
-              <a:rPr lang="ko-KR" altLang="en-US" sz="1050" b="1" dirty="0" err="1">
-                <a:solidFill>
-                  <a:srgbClr val="FF0000"/>
-                </a:solidFill>
-              </a:rPr>
-              <a:t>유량게</a:t>
-            </a:r>
-            <a:r>
-              <a:rPr lang="ko-KR" altLang="en-US" sz="1050" b="1" dirty="0">
-                <a:solidFill>
-                  <a:srgbClr val="FF0000"/>
-                </a:solidFill>
-              </a:rPr>
-              <a:t> 판넬 </a:t>
-            </a:r>
-            <a:r>
-              <a:rPr lang="en-US" altLang="ko-KR" sz="1050" b="1" dirty="0">
-                <a:solidFill>
-                  <a:srgbClr val="FF0000"/>
-                </a:solidFill>
-              </a:rPr>
-              <a:t>-&gt; </a:t>
-            </a:r>
-            <a:r>
-              <a:rPr lang="ko-KR" altLang="en-US" sz="1050" b="1" dirty="0">
-                <a:solidFill>
-                  <a:srgbClr val="FF0000"/>
-                </a:solidFill>
-              </a:rPr>
-              <a:t>맨홀 라인 파악 필요</a:t>
-            </a:r>
-            <a:r>
-              <a:rPr lang="en-US" altLang="ko-KR" sz="1050" b="1" dirty="0">
-                <a:solidFill>
-                  <a:srgbClr val="FF0000"/>
-                </a:solidFill>
-              </a:rPr>
-              <a:t>(</a:t>
-            </a:r>
-            <a:r>
-              <a:rPr lang="ko-KR" altLang="en-US" sz="1050" b="1" dirty="0">
-                <a:solidFill>
-                  <a:srgbClr val="FF0000"/>
-                </a:solidFill>
-              </a:rPr>
-              <a:t>컨트롤러방식 사용 안 할 시</a:t>
-            </a:r>
-            <a:r>
-              <a:rPr lang="en-US" altLang="ko-KR" sz="1050" b="1" dirty="0">
-                <a:solidFill>
-                  <a:srgbClr val="FF0000"/>
-                </a:solidFill>
-              </a:rPr>
-              <a:t>)</a:t>
-            </a:r>
-          </a:p>
-          <a:p>
-            <a:pPr marL="171450" indent="-171450">
-              <a:buFont typeface="Arial" panose="020B0604020202020204" pitchFamily="34" charset="0"/>
-              <a:buChar char="•"/>
-            </a:pPr>
-            <a:r>
-              <a:rPr lang="ko-KR" altLang="en-US" sz="1050" b="1" dirty="0">
-                <a:solidFill>
-                  <a:srgbClr val="FF0000"/>
-                </a:solidFill>
-              </a:rPr>
-              <a:t>각 유출유량계 판넬 </a:t>
-            </a:r>
-            <a:r>
-              <a:rPr lang="en-US" altLang="ko-KR" sz="1050" b="1" dirty="0">
-                <a:solidFill>
-                  <a:srgbClr val="FF0000"/>
-                </a:solidFill>
-              </a:rPr>
-              <a:t>-&gt; RCS </a:t>
-            </a:r>
-            <a:r>
-              <a:rPr lang="ko-KR" altLang="en-US" sz="1050" b="1" dirty="0">
-                <a:solidFill>
-                  <a:srgbClr val="FF0000"/>
-                </a:solidFill>
-              </a:rPr>
-              <a:t>통신라인 및 여분 확인 필요</a:t>
-            </a:r>
-            <a:endParaRPr lang="en-US" altLang="ko-KR" sz="1050" b="1" dirty="0">
-              <a:solidFill>
-                <a:srgbClr val="FF0000"/>
-              </a:solidFill>
-            </a:endParaRPr>
-          </a:p>
-          <a:p>
-            <a:pPr marL="171450" indent="-171450">
-              <a:buFont typeface="Arial" panose="020B0604020202020204" pitchFamily="34" charset="0"/>
-              <a:buChar char="•"/>
-            </a:pPr>
-            <a:r>
-              <a:rPr lang="ko-KR" altLang="en-US" sz="1050" b="1" dirty="0">
-                <a:solidFill>
-                  <a:srgbClr val="FF0000"/>
-                </a:solidFill>
-              </a:rPr>
-              <a:t>여과지동 통신라인 파악불가</a:t>
-            </a:r>
-            <a:r>
-              <a:rPr lang="en-US" altLang="ko-KR" sz="1050" b="1" dirty="0">
-                <a:solidFill>
-                  <a:srgbClr val="FF0000"/>
-                </a:solidFill>
-              </a:rPr>
-              <a:t>, </a:t>
-            </a:r>
-            <a:r>
-              <a:rPr lang="ko-KR" altLang="en-US" sz="1050" b="1" dirty="0">
-                <a:solidFill>
-                  <a:srgbClr val="FF0000"/>
-                </a:solidFill>
-              </a:rPr>
-              <a:t>담당자가 파악 후 회신</a:t>
-            </a:r>
-            <a:endParaRPr lang="en-US" altLang="ko-KR" sz="1050" b="1" dirty="0">
-              <a:solidFill>
-                <a:srgbClr val="FF0000"/>
-              </a:solidFill>
-            </a:endParaRPr>
-          </a:p>
-          <a:p>
-            <a:pPr marL="171450" indent="-171450">
-              <a:buFont typeface="Arial" panose="020B0604020202020204" pitchFamily="34" charset="0"/>
-              <a:buChar char="•"/>
-            </a:pPr>
-            <a:r>
-              <a:rPr lang="ko-KR" altLang="en-US" sz="1050" b="1" dirty="0" err="1">
-                <a:solidFill>
-                  <a:srgbClr val="FF0000"/>
-                </a:solidFill>
-              </a:rPr>
-              <a:t>경광등</a:t>
-            </a:r>
-            <a:r>
-              <a:rPr lang="en-US" altLang="ko-KR" sz="1050" b="1" dirty="0">
-                <a:solidFill>
-                  <a:srgbClr val="FF0000"/>
-                </a:solidFill>
-              </a:rPr>
-              <a:t>(</a:t>
-            </a:r>
-            <a:r>
-              <a:rPr lang="ko-KR" altLang="en-US" sz="1050" b="1" dirty="0">
-                <a:solidFill>
-                  <a:srgbClr val="FF0000"/>
-                </a:solidFill>
-              </a:rPr>
-              <a:t>농축 분배조동</a:t>
-            </a:r>
-            <a:r>
-              <a:rPr lang="en-US" altLang="ko-KR" sz="1050" b="1" dirty="0">
-                <a:solidFill>
-                  <a:srgbClr val="FF0000"/>
-                </a:solidFill>
-              </a:rPr>
-              <a:t>, </a:t>
-            </a:r>
-            <a:r>
-              <a:rPr lang="ko-KR" altLang="en-US" sz="1050" b="1" dirty="0">
-                <a:solidFill>
-                  <a:srgbClr val="FF0000"/>
-                </a:solidFill>
-              </a:rPr>
-              <a:t>여과지동</a:t>
-            </a:r>
-            <a:r>
-              <a:rPr lang="en-US" altLang="ko-KR" sz="1050" b="1" dirty="0">
-                <a:solidFill>
-                  <a:srgbClr val="FF0000"/>
-                </a:solidFill>
-              </a:rPr>
-              <a:t>) 2</a:t>
-            </a:r>
-            <a:r>
-              <a:rPr lang="ko-KR" altLang="en-US" sz="1050" b="1" dirty="0">
-                <a:solidFill>
-                  <a:srgbClr val="FF0000"/>
-                </a:solidFill>
-              </a:rPr>
-              <a:t>개소 설치 예정</a:t>
-            </a:r>
-            <a:endParaRPr lang="en-US" altLang="ko-KR" sz="1050" b="1" dirty="0">
-              <a:solidFill>
-                <a:srgbClr val="FF0000"/>
-              </a:solidFill>
-            </a:endParaRPr>
-          </a:p>
-          <a:p>
-            <a:pPr marL="171450" indent="-171450">
-              <a:buFont typeface="Arial" panose="020B0604020202020204" pitchFamily="34" charset="0"/>
-              <a:buChar char="•"/>
-            </a:pPr>
             <a:endParaRPr lang="en-US" altLang="ko-KR" sz="1050" b="1" dirty="0">
               <a:solidFill>
                 <a:srgbClr val="FF0000"/>
@@ -9566,45 +9307,8 @@
                 <a:latin typeface="휴먼엑스포" charset="0"/>
                 <a:ea typeface="문체부 바탕체" charset="0"/>
               </a:rPr>
-              <a:t>&gt; 3</a:t>
+              <a:t>&gt;</a:t>
             </a:r>
-            <a:r>
-              <a:rPr lang="ko-KR" altLang="en-US" sz="1400" b="1" dirty="0">
-                <a:solidFill>
-                  <a:schemeClr val="tx1"/>
-                </a:solidFill>
-                <a:latin typeface="휴먼엑스포" charset="0"/>
-                <a:ea typeface="문체부 바탕체" charset="0"/>
-              </a:rPr>
-              <a:t>단계 </a:t>
-            </a:r>
-            <a:r>
-              <a:rPr lang="ko-KR" altLang="en-US" sz="1400" b="1" dirty="0" err="1">
-                <a:solidFill>
-                  <a:schemeClr val="tx1"/>
-                </a:solidFill>
-                <a:latin typeface="휴먼엑스포" charset="0"/>
-                <a:ea typeface="문체부 바탕체" charset="0"/>
-              </a:rPr>
-              <a:t>유출유량계실</a:t>
-            </a:r>
-            <a:r>
-              <a:rPr lang="ko-KR" altLang="en-US" sz="1400" b="1" dirty="0">
-                <a:solidFill>
-                  <a:schemeClr val="tx1"/>
-                </a:solidFill>
-                <a:latin typeface="휴먼엑스포" charset="0"/>
-                <a:ea typeface="문체부 바탕체" charset="0"/>
-              </a:rPr>
-              <a:t> </a:t>
-            </a:r>
-            <a:endParaRPr lang="en-US" altLang="ko-KR" sz="1400" b="1" dirty="0">
-              <a:solidFill>
-                <a:schemeClr val="tx1"/>
-              </a:solidFill>
-              <a:latin typeface="휴먼엑스포" charset="0"/>
-              <a:ea typeface="문체부 바탕체" charset="0"/>
-            </a:endParaRPr>
           </a:p>
         </p:txBody>
       </p:sp>
@@ -9830,45 +9534,8 @@
                 <a:latin typeface="휴먼엑스포" charset="0"/>
                 <a:ea typeface="문체부 바탕체" charset="0"/>
               </a:rPr>
-              <a:t>&gt; 3</a:t>
+              <a:t>&gt;</a:t>
             </a:r>
-            <a:r>
-              <a:rPr lang="ko-KR" altLang="en-US" sz="1400" b="1" dirty="0">
-                <a:solidFill>
-                  <a:schemeClr val="tx1"/>
-                </a:solidFill>
-                <a:latin typeface="휴먼엑스포" charset="0"/>
-                <a:ea typeface="문체부 바탕체" charset="0"/>
-              </a:rPr>
-              <a:t>단계 </a:t>
-            </a:r>
-            <a:r>
-              <a:rPr lang="ko-KR" altLang="en-US" sz="1400" b="1" dirty="0" err="1">
-                <a:solidFill>
-                  <a:schemeClr val="tx1"/>
-                </a:solidFill>
-                <a:latin typeface="휴먼엑스포" charset="0"/>
-                <a:ea typeface="문체부 바탕체" charset="0"/>
-              </a:rPr>
-              <a:t>유출유량계실</a:t>
-            </a:r>
-            <a:r>
-              <a:rPr lang="ko-KR" altLang="en-US" sz="1400" b="1" dirty="0">
-                <a:solidFill>
-                  <a:schemeClr val="tx1"/>
-                </a:solidFill>
-                <a:latin typeface="휴먼엑스포" charset="0"/>
-                <a:ea typeface="문체부 바탕체" charset="0"/>
-              </a:rPr>
-              <a:t> </a:t>
-            </a:r>
-            <a:endParaRPr lang="en-US" altLang="ko-KR" sz="1400" b="1" dirty="0">
-              <a:solidFill>
-                <a:schemeClr val="tx1"/>
-              </a:solidFill>
-              <a:latin typeface="휴먼엑스포" charset="0"/>
-              <a:ea typeface="문체부 바탕체" charset="0"/>
-            </a:endParaRPr>
           </a:p>
         </p:txBody>
       </p:sp>
@@ -10099,45 +9766,8 @@
                 <a:latin typeface="휴먼엑스포" charset="0"/>
                 <a:ea typeface="문체부 바탕체" charset="0"/>
               </a:rPr>
-              <a:t>&gt; </a:t>
+              <a:t>&gt;</a:t>
             </a:r>
-            <a:r>
-              <a:rPr lang="ko-KR" altLang="en-US" sz="1400" b="1" dirty="0">
-                <a:solidFill>
-                  <a:schemeClr val="tx1"/>
-                </a:solidFill>
-                <a:latin typeface="휴먼엑스포" charset="0"/>
-                <a:ea typeface="문체부 바탕체" charset="0"/>
-              </a:rPr>
-              <a:t>생활 </a:t>
-            </a:r>
-            <a:r>
-              <a:rPr lang="ko-KR" altLang="en-US" sz="1400" b="1" dirty="0" err="1">
-                <a:solidFill>
-                  <a:schemeClr val="tx1"/>
-                </a:solidFill>
-                <a:latin typeface="휴먼엑스포" charset="0"/>
-                <a:ea typeface="문체부 바탕체" charset="0"/>
-              </a:rPr>
-              <a:t>유출유량계실</a:t>
-            </a:r>
-            <a:r>
-              <a:rPr lang="ko-KR" altLang="en-US" sz="1400" b="1" dirty="0">
-                <a:solidFill>
-                  <a:schemeClr val="tx1"/>
-                </a:solidFill>
-                <a:latin typeface="휴먼엑스포" charset="0"/>
-                <a:ea typeface="문체부 바탕체" charset="0"/>
-              </a:rPr>
-              <a:t> </a:t>
-            </a:r>
-            <a:endParaRPr lang="en-US" altLang="ko-KR" sz="1400" b="1" dirty="0">
-              <a:solidFill>
-                <a:schemeClr val="tx1"/>
-              </a:solidFill>
-              <a:latin typeface="휴먼엑스포" charset="0"/>
-              <a:ea typeface="문체부 바탕체" charset="0"/>
-            </a:endParaRPr>
           </a:p>
         </p:txBody>
       </p:sp>

</xml_diff>